<commit_message>
docs: the live app is up; drop "work in progress" from the deck
</commit_message>
<xml_diff>
--- a/docs/slides/Rahul_Ramachandran_ReconMind-ProjectSubmission.pptx
+++ b/docs/slides/Rahul_Ramachandran_ReconMind-ProjectSubmission.pptx
@@ -2435,6 +2435,10 @@
           </a:solidFill>
           <a:ln/>
         </p:spPr>
+        <p:txBody>
+          <a:bodyPr/>
+          <a:p/>
+        </p:txBody>
       </p:sp>
       <p:sp>
         <p:nvSpPr>
@@ -2457,6 +2461,10 @@
           </a:solidFill>
           <a:ln/>
         </p:spPr>
+        <p:txBody>
+          <a:bodyPr/>
+          <a:p/>
+        </p:txBody>
       </p:sp>
       <p:sp>
         <p:nvSpPr>
@@ -2656,6 +2664,10 @@
           </a:solidFill>
           <a:ln/>
         </p:spPr>
+        <p:txBody>
+          <a:bodyPr/>
+          <a:p/>
+        </p:txBody>
       </p:sp>
       <p:pic>
         <p:nvPicPr>
@@ -2823,7 +2835,7 @@
                 <a:ea typeface="Courier New" pitchFamily="34" charset="-122"/>
                 <a:cs typeface="Courier New" pitchFamily="34" charset="-120"/>
               </a:rPr>
-              <a:t>  (work in progress)</a:t>
+              <a:t/>
             </a:r>
             <a:endParaRPr lang="en-US" sz="1100" dirty="0"/>
           </a:p>
@@ -2857,6 +2869,10 @@
             </a:outerShdw>
           </a:effectLst>
         </p:spPr>
+        <p:txBody>
+          <a:bodyPr/>
+          <a:p/>
+        </p:txBody>
       </p:sp>
       <p:sp>
         <p:nvSpPr>
@@ -2948,6 +2964,10 @@
             </a:outerShdw>
           </a:effectLst>
         </p:spPr>
+        <p:txBody>
+          <a:bodyPr/>
+          <a:p/>
+        </p:txBody>
       </p:sp>
       <p:sp>
         <p:nvSpPr>
@@ -3142,6 +3162,10 @@
             </a:outerShdw>
           </a:effectLst>
         </p:spPr>
+        <p:txBody>
+          <a:bodyPr/>
+          <a:p/>
+        </p:txBody>
       </p:sp>
       <p:sp>
         <p:nvSpPr>
@@ -3162,6 +3186,10 @@
           </a:solidFill>
           <a:ln/>
         </p:spPr>
+        <p:txBody>
+          <a:bodyPr/>
+          <a:p/>
+        </p:txBody>
       </p:sp>
       <p:pic>
         <p:nvPicPr>
@@ -3296,6 +3324,10 @@
             </a:outerShdw>
           </a:effectLst>
         </p:spPr>
+        <p:txBody>
+          <a:bodyPr/>
+          <a:p/>
+        </p:txBody>
       </p:sp>
       <p:sp>
         <p:nvSpPr>
@@ -3316,6 +3348,10 @@
           </a:solidFill>
           <a:ln/>
         </p:spPr>
+        <p:txBody>
+          <a:bodyPr/>
+          <a:p/>
+        </p:txBody>
       </p:sp>
       <p:pic>
         <p:nvPicPr>
@@ -3450,6 +3486,10 @@
             </a:outerShdw>
           </a:effectLst>
         </p:spPr>
+        <p:txBody>
+          <a:bodyPr/>
+          <a:p/>
+        </p:txBody>
       </p:sp>
       <p:sp>
         <p:nvSpPr>
@@ -3470,6 +3510,10 @@
           </a:solidFill>
           <a:ln/>
         </p:spPr>
+        <p:txBody>
+          <a:bodyPr/>
+          <a:p/>
+        </p:txBody>
       </p:sp>
       <p:pic>
         <p:nvPicPr>
@@ -3604,6 +3648,10 @@
             </a:outerShdw>
           </a:effectLst>
         </p:spPr>
+        <p:txBody>
+          <a:bodyPr/>
+          <a:p/>
+        </p:txBody>
       </p:sp>
       <p:sp>
         <p:nvSpPr>
@@ -3624,6 +3672,10 @@
           </a:solidFill>
           <a:ln/>
         </p:spPr>
+        <p:txBody>
+          <a:bodyPr/>
+          <a:p/>
+        </p:txBody>
       </p:sp>
       <p:pic>
         <p:nvPicPr>
@@ -3751,6 +3803,10 @@
           </a:solidFill>
           <a:ln/>
         </p:spPr>
+        <p:txBody>
+          <a:bodyPr/>
+          <a:p/>
+        </p:txBody>
       </p:sp>
       <p:sp>
         <p:nvSpPr>
@@ -3854,6 +3910,10 @@
           </a:solidFill>
           <a:ln/>
         </p:spPr>
+        <p:txBody>
+          <a:bodyPr/>
+          <a:p/>
+        </p:txBody>
       </p:sp>
       <p:sp>
         <p:nvSpPr>
@@ -3957,6 +4017,10 @@
           </a:solidFill>
           <a:ln/>
         </p:spPr>
+        <p:txBody>
+          <a:bodyPr/>
+          <a:p/>
+        </p:txBody>
       </p:sp>
       <p:sp>
         <p:nvSpPr>
@@ -4248,6 +4312,10 @@
             </a:outerShdw>
           </a:effectLst>
         </p:spPr>
+        <p:txBody>
+          <a:bodyPr/>
+          <a:p/>
+        </p:txBody>
       </p:sp>
       <p:sp>
         <p:nvSpPr>
@@ -4268,6 +4336,10 @@
           </a:solidFill>
           <a:ln/>
         </p:spPr>
+        <p:txBody>
+          <a:bodyPr/>
+          <a:p/>
+        </p:txBody>
       </p:sp>
       <p:pic>
         <p:nvPicPr>
@@ -4543,6 +4615,10 @@
             </a:outerShdw>
           </a:effectLst>
         </p:spPr>
+        <p:txBody>
+          <a:bodyPr/>
+          <a:p/>
+        </p:txBody>
       </p:sp>
       <p:sp>
         <p:nvSpPr>
@@ -4563,6 +4639,10 @@
           </a:solidFill>
           <a:ln/>
         </p:spPr>
+        <p:txBody>
+          <a:bodyPr/>
+          <a:p/>
+        </p:txBody>
       </p:sp>
       <p:pic>
         <p:nvPicPr>
@@ -4831,6 +4911,10 @@
           </a:solidFill>
           <a:ln/>
         </p:spPr>
+        <p:txBody>
+          <a:bodyPr/>
+          <a:p/>
+        </p:txBody>
       </p:sp>
       <p:sp>
         <p:nvSpPr>
@@ -4934,6 +5018,10 @@
           </a:solidFill>
           <a:ln/>
         </p:spPr>
+        <p:txBody>
+          <a:bodyPr/>
+          <a:p/>
+        </p:txBody>
       </p:sp>
       <p:sp>
         <p:nvSpPr>
@@ -5037,6 +5125,10 @@
           </a:solidFill>
           <a:ln/>
         </p:spPr>
+        <p:txBody>
+          <a:bodyPr/>
+          <a:p/>
+        </p:txBody>
       </p:sp>
       <p:sp>
         <p:nvSpPr>
@@ -5140,6 +5232,10 @@
           </a:solidFill>
           <a:ln/>
         </p:spPr>
+        <p:txBody>
+          <a:bodyPr/>
+          <a:p/>
+        </p:txBody>
       </p:sp>
       <p:sp>
         <p:nvSpPr>
@@ -5431,6 +5527,10 @@
             </a:outerShdw>
           </a:effectLst>
         </p:spPr>
+        <p:txBody>
+          <a:bodyPr/>
+          <a:p/>
+        </p:txBody>
       </p:sp>
       <p:sp>
         <p:nvSpPr>
@@ -5451,6 +5551,10 @@
           </a:solidFill>
           <a:ln/>
         </p:spPr>
+        <p:txBody>
+          <a:bodyPr/>
+          <a:p/>
+        </p:txBody>
       </p:sp>
       <p:pic>
         <p:nvPicPr>
@@ -5637,6 +5741,10 @@
             </a:outerShdw>
           </a:effectLst>
         </p:spPr>
+        <p:txBody>
+          <a:bodyPr/>
+          <a:p/>
+        </p:txBody>
       </p:sp>
       <p:sp>
         <p:nvSpPr>
@@ -5657,6 +5765,10 @@
           </a:solidFill>
           <a:ln/>
         </p:spPr>
+        <p:txBody>
+          <a:bodyPr/>
+          <a:p/>
+        </p:txBody>
       </p:sp>
       <p:pic>
         <p:nvPicPr>
@@ -5843,6 +5955,10 @@
             </a:outerShdw>
           </a:effectLst>
         </p:spPr>
+        <p:txBody>
+          <a:bodyPr/>
+          <a:p/>
+        </p:txBody>
       </p:sp>
       <p:sp>
         <p:nvSpPr>
@@ -5863,6 +5979,10 @@
           </a:solidFill>
           <a:ln/>
         </p:spPr>
+        <p:txBody>
+          <a:bodyPr/>
+          <a:p/>
+        </p:txBody>
       </p:sp>
       <p:pic>
         <p:nvPicPr>
@@ -6042,6 +6162,10 @@
           </a:solidFill>
           <a:ln/>
         </p:spPr>
+        <p:txBody>
+          <a:bodyPr/>
+          <a:p/>
+        </p:txBody>
       </p:sp>
       <p:sp>
         <p:nvSpPr>
@@ -6108,6 +6232,10 @@
             <a:prstDash val="solid"/>
           </a:ln>
         </p:spPr>
+        <p:txBody>
+          <a:bodyPr/>
+          <a:p/>
+        </p:txBody>
       </p:sp>
       <p:sp>
         <p:nvSpPr>
@@ -6174,6 +6302,10 @@
             <a:prstDash val="solid"/>
           </a:ln>
         </p:spPr>
+        <p:txBody>
+          <a:bodyPr/>
+          <a:p/>
+        </p:txBody>
       </p:sp>
       <p:sp>
         <p:nvSpPr>
@@ -6240,6 +6372,10 @@
             <a:prstDash val="solid"/>
           </a:ln>
         </p:spPr>
+        <p:txBody>
+          <a:bodyPr/>
+          <a:p/>
+        </p:txBody>
       </p:sp>
       <p:sp>
         <p:nvSpPr>
@@ -6306,6 +6442,10 @@
             <a:prstDash val="solid"/>
           </a:ln>
         </p:spPr>
+        <p:txBody>
+          <a:bodyPr/>
+          <a:p/>
+        </p:txBody>
       </p:sp>
       <p:sp>
         <p:nvSpPr>
@@ -6372,6 +6512,10 @@
             <a:prstDash val="solid"/>
           </a:ln>
         </p:spPr>
+        <p:txBody>
+          <a:bodyPr/>
+          <a:p/>
+        </p:txBody>
       </p:sp>
       <p:sp>
         <p:nvSpPr>
@@ -6621,6 +6765,10 @@
             </a:outerShdw>
           </a:effectLst>
         </p:spPr>
+        <p:txBody>
+          <a:bodyPr/>
+          <a:p/>
+        </p:txBody>
       </p:sp>
       <p:sp>
         <p:nvSpPr>
@@ -6641,6 +6789,10 @@
           </a:solidFill>
           <a:ln/>
         </p:spPr>
+        <p:txBody>
+          <a:bodyPr/>
+          <a:p/>
+        </p:txBody>
       </p:sp>
       <p:pic>
         <p:nvPicPr>
@@ -6775,6 +6927,10 @@
             </a:outerShdw>
           </a:effectLst>
         </p:spPr>
+        <p:txBody>
+          <a:bodyPr/>
+          <a:p/>
+        </p:txBody>
       </p:sp>
       <p:sp>
         <p:nvSpPr>
@@ -6795,6 +6951,10 @@
           </a:solidFill>
           <a:ln/>
         </p:spPr>
+        <p:txBody>
+          <a:bodyPr/>
+          <a:p/>
+        </p:txBody>
       </p:sp>
       <p:pic>
         <p:nvPicPr>
@@ -6929,6 +7089,10 @@
             </a:outerShdw>
           </a:effectLst>
         </p:spPr>
+        <p:txBody>
+          <a:bodyPr/>
+          <a:p/>
+        </p:txBody>
       </p:sp>
       <p:sp>
         <p:nvSpPr>
@@ -6949,6 +7113,10 @@
           </a:solidFill>
           <a:ln/>
         </p:spPr>
+        <p:txBody>
+          <a:bodyPr/>
+          <a:p/>
+        </p:txBody>
       </p:sp>
       <p:pic>
         <p:nvPicPr>
@@ -7083,6 +7251,10 @@
             </a:outerShdw>
           </a:effectLst>
         </p:spPr>
+        <p:txBody>
+          <a:bodyPr/>
+          <a:p/>
+        </p:txBody>
       </p:sp>
       <p:sp>
         <p:nvSpPr>
@@ -7103,6 +7275,10 @@
           </a:solidFill>
           <a:ln/>
         </p:spPr>
+        <p:txBody>
+          <a:bodyPr/>
+          <a:p/>
+        </p:txBody>
       </p:sp>
       <p:pic>
         <p:nvPicPr>
@@ -7237,6 +7413,10 @@
             </a:outerShdw>
           </a:effectLst>
         </p:spPr>
+        <p:txBody>
+          <a:bodyPr/>
+          <a:p/>
+        </p:txBody>
       </p:sp>
       <p:sp>
         <p:nvSpPr>
@@ -7257,6 +7437,10 @@
           </a:solidFill>
           <a:ln/>
         </p:spPr>
+        <p:txBody>
+          <a:bodyPr/>
+          <a:p/>
+        </p:txBody>
       </p:sp>
       <p:pic>
         <p:nvPicPr>
@@ -7391,6 +7575,10 @@
             </a:outerShdw>
           </a:effectLst>
         </p:spPr>
+        <p:txBody>
+          <a:bodyPr/>
+          <a:p/>
+        </p:txBody>
       </p:sp>
       <p:sp>
         <p:nvSpPr>
@@ -7411,6 +7599,10 @@
           </a:solidFill>
           <a:ln/>
         </p:spPr>
+        <p:txBody>
+          <a:bodyPr/>
+          <a:p/>
+        </p:txBody>
       </p:sp>
       <p:pic>
         <p:nvPicPr>
@@ -7726,6 +7918,10 @@
             </a:outerShdw>
           </a:effectLst>
         </p:spPr>
+        <p:txBody>
+          <a:bodyPr/>
+          <a:p/>
+        </p:txBody>
       </p:sp>
       <p:sp>
         <p:nvSpPr>
@@ -7792,6 +7988,10 @@
             <a:prstDash val="solid"/>
           </a:ln>
         </p:spPr>
+        <p:txBody>
+          <a:bodyPr/>
+          <a:p/>
+        </p:txBody>
       </p:sp>
       <p:sp>
         <p:nvSpPr>
@@ -7858,6 +8058,10 @@
             <a:prstDash val="solid"/>
           </a:ln>
         </p:spPr>
+        <p:txBody>
+          <a:bodyPr/>
+          <a:p/>
+        </p:txBody>
       </p:sp>
       <p:sp>
         <p:nvSpPr>
@@ -7924,6 +8128,10 @@
             <a:prstDash val="solid"/>
           </a:ln>
         </p:spPr>
+        <p:txBody>
+          <a:bodyPr/>
+          <a:p/>
+        </p:txBody>
       </p:sp>
       <p:sp>
         <p:nvSpPr>
@@ -7990,6 +8198,10 @@
             <a:prstDash val="solid"/>
           </a:ln>
         </p:spPr>
+        <p:txBody>
+          <a:bodyPr/>
+          <a:p/>
+        </p:txBody>
       </p:sp>
       <p:sp>
         <p:nvSpPr>
@@ -8058,6 +8270,10 @@
             </a:outerShdw>
           </a:effectLst>
         </p:spPr>
+        <p:txBody>
+          <a:bodyPr/>
+          <a:p/>
+        </p:txBody>
       </p:sp>
       <p:sp>
         <p:nvSpPr>
@@ -8124,6 +8340,10 @@
             <a:prstDash val="solid"/>
           </a:ln>
         </p:spPr>
+        <p:txBody>
+          <a:bodyPr/>
+          <a:p/>
+        </p:txBody>
       </p:sp>
       <p:sp>
         <p:nvSpPr>
@@ -8190,6 +8410,10 @@
             <a:prstDash val="solid"/>
           </a:ln>
         </p:spPr>
+        <p:txBody>
+          <a:bodyPr/>
+          <a:p/>
+        </p:txBody>
       </p:sp>
       <p:sp>
         <p:nvSpPr>
@@ -8256,6 +8480,10 @@
             <a:prstDash val="solid"/>
           </a:ln>
         </p:spPr>
+        <p:txBody>
+          <a:bodyPr/>
+          <a:p/>
+        </p:txBody>
       </p:sp>
       <p:sp>
         <p:nvSpPr>
@@ -8322,6 +8550,10 @@
             <a:prstDash val="solid"/>
           </a:ln>
         </p:spPr>
+        <p:txBody>
+          <a:bodyPr/>
+          <a:p/>
+        </p:txBody>
       </p:sp>
       <p:sp>
         <p:nvSpPr>
@@ -8390,6 +8622,10 @@
             </a:outerShdw>
           </a:effectLst>
         </p:spPr>
+        <p:txBody>
+          <a:bodyPr/>
+          <a:p/>
+        </p:txBody>
       </p:sp>
       <p:sp>
         <p:nvSpPr>
@@ -8456,6 +8692,10 @@
             <a:prstDash val="solid"/>
           </a:ln>
         </p:spPr>
+        <p:txBody>
+          <a:bodyPr/>
+          <a:p/>
+        </p:txBody>
       </p:sp>
       <p:sp>
         <p:nvSpPr>
@@ -8522,6 +8762,10 @@
             <a:prstDash val="solid"/>
           </a:ln>
         </p:spPr>
+        <p:txBody>
+          <a:bodyPr/>
+          <a:p/>
+        </p:txBody>
       </p:sp>
       <p:sp>
         <p:nvSpPr>
@@ -8588,6 +8832,10 @@
             <a:prstDash val="solid"/>
           </a:ln>
         </p:spPr>
+        <p:txBody>
+          <a:bodyPr/>
+          <a:p/>
+        </p:txBody>
       </p:sp>
       <p:sp>
         <p:nvSpPr>
@@ -8654,6 +8902,10 @@
             <a:prstDash val="solid"/>
           </a:ln>
         </p:spPr>
+        <p:txBody>
+          <a:bodyPr/>
+          <a:p/>
+        </p:txBody>
       </p:sp>
       <p:sp>
         <p:nvSpPr>
@@ -8722,6 +8974,10 @@
             </a:outerShdw>
           </a:effectLst>
         </p:spPr>
+        <p:txBody>
+          <a:bodyPr/>
+          <a:p/>
+        </p:txBody>
       </p:sp>
       <p:sp>
         <p:nvSpPr>
@@ -8788,6 +9044,10 @@
             <a:prstDash val="solid"/>
           </a:ln>
         </p:spPr>
+        <p:txBody>
+          <a:bodyPr/>
+          <a:p/>
+        </p:txBody>
       </p:sp>
       <p:sp>
         <p:nvSpPr>
@@ -8854,6 +9114,10 @@
             <a:prstDash val="solid"/>
           </a:ln>
         </p:spPr>
+        <p:txBody>
+          <a:bodyPr/>
+          <a:p/>
+        </p:txBody>
       </p:sp>
       <p:sp>
         <p:nvSpPr>
@@ -8920,6 +9184,10 @@
             <a:prstDash val="solid"/>
           </a:ln>
         </p:spPr>
+        <p:txBody>
+          <a:bodyPr/>
+          <a:p/>
+        </p:txBody>
       </p:sp>
       <p:sp>
         <p:nvSpPr>
@@ -8986,6 +9254,10 @@
             <a:prstDash val="solid"/>
           </a:ln>
         </p:spPr>
+        <p:txBody>
+          <a:bodyPr/>
+          <a:p/>
+        </p:txBody>
       </p:sp>
       <p:sp>
         <p:nvSpPr>
@@ -9054,6 +9326,10 @@
             </a:outerShdw>
           </a:effectLst>
         </p:spPr>
+        <p:txBody>
+          <a:bodyPr/>
+          <a:p/>
+        </p:txBody>
       </p:sp>
       <p:sp>
         <p:nvSpPr>
@@ -9120,6 +9396,10 @@
             <a:prstDash val="solid"/>
           </a:ln>
         </p:spPr>
+        <p:txBody>
+          <a:bodyPr/>
+          <a:p/>
+        </p:txBody>
       </p:sp>
       <p:sp>
         <p:nvSpPr>
@@ -9186,6 +9466,10 @@
             <a:prstDash val="solid"/>
           </a:ln>
         </p:spPr>
+        <p:txBody>
+          <a:bodyPr/>
+          <a:p/>
+        </p:txBody>
       </p:sp>
       <p:sp>
         <p:nvSpPr>
@@ -9252,6 +9536,10 @@
             <a:prstDash val="solid"/>
           </a:ln>
         </p:spPr>
+        <p:txBody>
+          <a:bodyPr/>
+          <a:p/>
+        </p:txBody>
       </p:sp>
       <p:sp>
         <p:nvSpPr>
@@ -9318,6 +9606,10 @@
             <a:prstDash val="solid"/>
           </a:ln>
         </p:spPr>
+        <p:txBody>
+          <a:bodyPr/>
+          <a:p/>
+        </p:txBody>
       </p:sp>
       <p:sp>
         <p:nvSpPr>
@@ -9386,6 +9678,10 @@
             </a:outerShdw>
           </a:effectLst>
         </p:spPr>
+        <p:txBody>
+          <a:bodyPr/>
+          <a:p/>
+        </p:txBody>
       </p:sp>
       <p:sp>
         <p:nvSpPr>
@@ -9452,6 +9748,10 @@
             <a:prstDash val="solid"/>
           </a:ln>
         </p:spPr>
+        <p:txBody>
+          <a:bodyPr/>
+          <a:p/>
+        </p:txBody>
       </p:sp>
       <p:sp>
         <p:nvSpPr>
@@ -9518,6 +9818,10 @@
             <a:prstDash val="solid"/>
           </a:ln>
         </p:spPr>
+        <p:txBody>
+          <a:bodyPr/>
+          <a:p/>
+        </p:txBody>
       </p:sp>
       <p:sp>
         <p:nvSpPr>
@@ -9584,6 +9888,10 @@
             <a:prstDash val="solid"/>
           </a:ln>
         </p:spPr>
+        <p:txBody>
+          <a:bodyPr/>
+          <a:p/>
+        </p:txBody>
       </p:sp>
       <p:sp>
         <p:nvSpPr>
@@ -9650,6 +9958,10 @@
             <a:prstDash val="solid"/>
           </a:ln>
         </p:spPr>
+        <p:txBody>
+          <a:bodyPr/>
+          <a:p/>
+        </p:txBody>
       </p:sp>
       <p:sp>
         <p:nvSpPr>
@@ -9890,6 +10202,10 @@
           </a:solidFill>
           <a:ln/>
         </p:spPr>
+        <p:txBody>
+          <a:bodyPr/>
+          <a:p/>
+        </p:txBody>
       </p:sp>
       <p:sp>
         <p:nvSpPr>
@@ -9910,6 +10226,10 @@
           </a:solidFill>
           <a:ln/>
         </p:spPr>
+        <p:txBody>
+          <a:bodyPr/>
+          <a:p/>
+        </p:txBody>
       </p:sp>
       <p:sp>
         <p:nvSpPr>
@@ -9978,6 +10298,10 @@
             </a:outerShdw>
           </a:effectLst>
         </p:spPr>
+        <p:txBody>
+          <a:bodyPr/>
+          <a:p/>
+        </p:txBody>
       </p:sp>
       <p:sp>
         <p:nvSpPr>
@@ -10079,6 +10403,10 @@
           </a:solidFill>
           <a:ln/>
         </p:spPr>
+        <p:txBody>
+          <a:bodyPr/>
+          <a:p/>
+        </p:txBody>
       </p:sp>
       <p:sp>
         <p:nvSpPr>
@@ -10147,6 +10475,10 @@
             </a:outerShdw>
           </a:effectLst>
         </p:spPr>
+        <p:txBody>
+          <a:bodyPr/>
+          <a:p/>
+        </p:txBody>
       </p:sp>
       <p:sp>
         <p:nvSpPr>
@@ -10248,6 +10580,10 @@
           </a:solidFill>
           <a:ln/>
         </p:spPr>
+        <p:txBody>
+          <a:bodyPr/>
+          <a:p/>
+        </p:txBody>
       </p:sp>
       <p:sp>
         <p:nvSpPr>
@@ -10316,6 +10652,10 @@
             </a:outerShdw>
           </a:effectLst>
         </p:spPr>
+        <p:txBody>
+          <a:bodyPr/>
+          <a:p/>
+        </p:txBody>
       </p:sp>
       <p:sp>
         <p:nvSpPr>
@@ -10417,6 +10757,10 @@
           </a:solidFill>
           <a:ln/>
         </p:spPr>
+        <p:txBody>
+          <a:bodyPr/>
+          <a:p/>
+        </p:txBody>
       </p:sp>
       <p:sp>
         <p:nvSpPr>
@@ -10485,6 +10829,10 @@
             </a:outerShdw>
           </a:effectLst>
         </p:spPr>
+        <p:txBody>
+          <a:bodyPr/>
+          <a:p/>
+        </p:txBody>
       </p:sp>
       <p:sp>
         <p:nvSpPr>
@@ -10588,6 +10936,10 @@
           </a:solidFill>
           <a:ln/>
         </p:spPr>
+        <p:txBody>
+          <a:bodyPr/>
+          <a:p/>
+        </p:txBody>
       </p:sp>
       <p:sp>
         <p:nvSpPr>
@@ -10850,6 +11202,10 @@
           </a:solidFill>
           <a:ln/>
         </p:spPr>
+        <p:txBody>
+          <a:bodyPr/>
+          <a:p/>
+        </p:txBody>
       </p:sp>
       <p:sp>
         <p:nvSpPr>
@@ -10870,6 +11226,10 @@
           </a:solidFill>
           <a:ln/>
         </p:spPr>
+        <p:txBody>
+          <a:bodyPr/>
+          <a:p/>
+        </p:txBody>
       </p:sp>
       <p:pic>
         <p:nvPicPr>
@@ -10956,6 +11316,10 @@
           </a:solidFill>
           <a:ln/>
         </p:spPr>
+        <p:txBody>
+          <a:bodyPr/>
+          <a:p/>
+        </p:txBody>
       </p:sp>
       <p:sp>
         <p:nvSpPr>
@@ -11020,6 +11384,10 @@
           </a:solidFill>
           <a:ln/>
         </p:spPr>
+        <p:txBody>
+          <a:bodyPr/>
+          <a:p/>
+        </p:txBody>
       </p:sp>
       <p:sp>
         <p:nvSpPr>
@@ -11040,6 +11408,10 @@
           </a:solidFill>
           <a:ln/>
         </p:spPr>
+        <p:txBody>
+          <a:bodyPr/>
+          <a:p/>
+        </p:txBody>
       </p:sp>
       <p:pic>
         <p:nvPicPr>
@@ -11126,6 +11498,10 @@
           </a:solidFill>
           <a:ln/>
         </p:spPr>
+        <p:txBody>
+          <a:bodyPr/>
+          <a:p/>
+        </p:txBody>
       </p:sp>
       <p:sp>
         <p:nvSpPr>
@@ -11190,6 +11566,10 @@
           </a:solidFill>
           <a:ln/>
         </p:spPr>
+        <p:txBody>
+          <a:bodyPr/>
+          <a:p/>
+        </p:txBody>
       </p:sp>
       <p:sp>
         <p:nvSpPr>
@@ -11210,6 +11590,10 @@
           </a:solidFill>
           <a:ln/>
         </p:spPr>
+        <p:txBody>
+          <a:bodyPr/>
+          <a:p/>
+        </p:txBody>
       </p:sp>
       <p:pic>
         <p:nvPicPr>
@@ -11296,6 +11680,10 @@
           </a:solidFill>
           <a:ln/>
         </p:spPr>
+        <p:txBody>
+          <a:bodyPr/>
+          <a:p/>
+        </p:txBody>
       </p:sp>
       <p:sp>
         <p:nvSpPr>
@@ -11360,6 +11748,10 @@
           </a:solidFill>
           <a:ln/>
         </p:spPr>
+        <p:txBody>
+          <a:bodyPr/>
+          <a:p/>
+        </p:txBody>
       </p:sp>
       <p:sp>
         <p:nvSpPr>
@@ -11380,6 +11772,10 @@
           </a:solidFill>
           <a:ln/>
         </p:spPr>
+        <p:txBody>
+          <a:bodyPr/>
+          <a:p/>
+        </p:txBody>
       </p:sp>
       <p:pic>
         <p:nvPicPr>
@@ -11466,6 +11862,10 @@
           </a:solidFill>
           <a:ln/>
         </p:spPr>
+        <p:txBody>
+          <a:bodyPr/>
+          <a:p/>
+        </p:txBody>
       </p:sp>
       <p:sp>
         <p:nvSpPr>
@@ -11530,6 +11930,10 @@
           </a:solidFill>
           <a:ln/>
         </p:spPr>
+        <p:txBody>
+          <a:bodyPr/>
+          <a:p/>
+        </p:txBody>
       </p:sp>
       <p:sp>
         <p:nvSpPr>
@@ -11550,6 +11954,10 @@
           </a:solidFill>
           <a:ln/>
         </p:spPr>
+        <p:txBody>
+          <a:bodyPr/>
+          <a:p/>
+        </p:txBody>
       </p:sp>
       <p:pic>
         <p:nvPicPr>
@@ -11636,6 +12044,10 @@
           </a:solidFill>
           <a:ln/>
         </p:spPr>
+        <p:txBody>
+          <a:bodyPr/>
+          <a:p/>
+        </p:txBody>
       </p:sp>
       <p:sp>
         <p:nvSpPr>
@@ -11927,6 +12339,10 @@
             </a:outerShdw>
           </a:effectLst>
         </p:spPr>
+        <p:txBody>
+          <a:bodyPr/>
+          <a:p/>
+        </p:txBody>
       </p:sp>
       <p:sp>
         <p:nvSpPr>
@@ -11947,6 +12363,10 @@
           </a:solidFill>
           <a:ln/>
         </p:spPr>
+        <p:txBody>
+          <a:bodyPr/>
+          <a:p/>
+        </p:txBody>
       </p:sp>
       <p:pic>
         <p:nvPicPr>
@@ -12120,6 +12540,10 @@
             </a:outerShdw>
           </a:effectLst>
         </p:spPr>
+        <p:txBody>
+          <a:bodyPr/>
+          <a:p/>
+        </p:txBody>
       </p:sp>
       <p:sp>
         <p:nvSpPr>
@@ -12140,6 +12564,10 @@
           </a:solidFill>
           <a:ln/>
         </p:spPr>
+        <p:txBody>
+          <a:bodyPr/>
+          <a:p/>
+        </p:txBody>
       </p:sp>
       <p:pic>
         <p:nvPicPr>
@@ -12313,6 +12741,10 @@
             </a:outerShdw>
           </a:effectLst>
         </p:spPr>
+        <p:txBody>
+          <a:bodyPr/>
+          <a:p/>
+        </p:txBody>
       </p:sp>
       <p:sp>
         <p:nvSpPr>
@@ -12333,6 +12765,10 @@
           </a:solidFill>
           <a:ln/>
         </p:spPr>
+        <p:txBody>
+          <a:bodyPr/>
+          <a:p/>
+        </p:txBody>
       </p:sp>
       <p:pic>
         <p:nvPicPr>
@@ -12506,6 +12942,10 @@
             </a:outerShdw>
           </a:effectLst>
         </p:spPr>
+        <p:txBody>
+          <a:bodyPr/>
+          <a:p/>
+        </p:txBody>
       </p:sp>
       <p:sp>
         <p:nvSpPr>
@@ -12788,6 +13228,10 @@
           </a:solidFill>
           <a:ln/>
         </p:spPr>
+        <p:txBody>
+          <a:bodyPr/>
+          <a:p/>
+        </p:txBody>
       </p:sp>
       <p:sp>
         <p:nvSpPr>
@@ -12808,6 +13252,10 @@
           </a:solidFill>
           <a:ln/>
         </p:spPr>
+        <p:txBody>
+          <a:bodyPr/>
+          <a:p/>
+        </p:txBody>
       </p:sp>
       <p:pic>
         <p:nvPicPr>
@@ -12935,6 +13383,10 @@
           </a:solidFill>
           <a:ln/>
         </p:spPr>
+        <p:txBody>
+          <a:bodyPr/>
+          <a:p/>
+        </p:txBody>
       </p:sp>
       <p:sp>
         <p:nvSpPr>
@@ -13038,6 +13490,10 @@
           </a:solidFill>
           <a:ln/>
         </p:spPr>
+        <p:txBody>
+          <a:bodyPr/>
+          <a:p/>
+        </p:txBody>
       </p:sp>
       <p:sp>
         <p:nvSpPr>
@@ -13141,6 +13597,10 @@
           </a:solidFill>
           <a:ln/>
         </p:spPr>
+        <p:txBody>
+          <a:bodyPr/>
+          <a:p/>
+        </p:txBody>
       </p:sp>
       <p:sp>
         <p:nvSpPr>
@@ -13244,6 +13704,10 @@
           </a:solidFill>
           <a:ln/>
         </p:spPr>
+        <p:txBody>
+          <a:bodyPr/>
+          <a:p/>
+        </p:txBody>
       </p:sp>
       <p:sp>
         <p:nvSpPr>
@@ -13347,6 +13811,10 @@
           </a:solidFill>
           <a:ln/>
         </p:spPr>
+        <p:txBody>
+          <a:bodyPr/>
+          <a:p/>
+        </p:txBody>
       </p:sp>
       <p:sp>
         <p:nvSpPr>
@@ -13450,6 +13918,10 @@
           </a:solidFill>
           <a:ln/>
         </p:spPr>
+        <p:txBody>
+          <a:bodyPr/>
+          <a:p/>
+        </p:txBody>
       </p:sp>
       <p:sp>
         <p:nvSpPr>
@@ -13674,7 +14146,7 @@
                 <a:ea typeface="Courier New" pitchFamily="34" charset="-122"/>
                 <a:cs typeface="Courier New" pitchFamily="34" charset="-120"/>
               </a:rPr>
-              <a:t>  (work in progress)</a:t>
+              <a:t/>
             </a:r>
             <a:endParaRPr lang="en-US" sz="1050" dirty="0"/>
           </a:p>
@@ -13843,6 +14315,10 @@
           </a:solidFill>
           <a:ln/>
         </p:spPr>
+        <p:txBody>
+          <a:bodyPr/>
+          <a:p/>
+        </p:txBody>
       </p:sp>
       <p:sp>
         <p:nvSpPr>
@@ -13863,6 +14339,10 @@
           </a:solidFill>
           <a:ln/>
         </p:spPr>
+        <p:txBody>
+          <a:bodyPr/>
+          <a:p/>
+        </p:txBody>
       </p:sp>
       <p:pic>
         <p:nvPicPr>
@@ -13987,6 +14467,10 @@
           </a:solidFill>
           <a:ln/>
         </p:spPr>
+        <p:txBody>
+          <a:bodyPr/>
+          <a:p/>
+        </p:txBody>
       </p:sp>
       <p:sp>
         <p:nvSpPr>
@@ -14007,6 +14491,10 @@
           </a:solidFill>
           <a:ln/>
         </p:spPr>
+        <p:txBody>
+          <a:bodyPr/>
+          <a:p/>
+        </p:txBody>
       </p:sp>
       <p:pic>
         <p:nvPicPr>
@@ -14131,6 +14619,10 @@
           </a:solidFill>
           <a:ln/>
         </p:spPr>
+        <p:txBody>
+          <a:bodyPr/>
+          <a:p/>
+        </p:txBody>
       </p:sp>
       <p:sp>
         <p:nvSpPr>
@@ -14151,6 +14643,10 @@
           </a:solidFill>
           <a:ln/>
         </p:spPr>
+        <p:txBody>
+          <a:bodyPr/>
+          <a:p/>
+        </p:txBody>
       </p:sp>
       <p:pic>
         <p:nvPicPr>
@@ -14275,6 +14771,10 @@
           </a:solidFill>
           <a:ln/>
         </p:spPr>
+        <p:txBody>
+          <a:bodyPr/>
+          <a:p/>
+        </p:txBody>
       </p:sp>
       <p:sp>
         <p:nvSpPr>
@@ -14295,6 +14795,10 @@
           </a:solidFill>
           <a:ln/>
         </p:spPr>
+        <p:txBody>
+          <a:bodyPr/>
+          <a:p/>
+        </p:txBody>
       </p:sp>
       <p:pic>
         <p:nvPicPr>
@@ -14419,6 +14923,10 @@
           </a:solidFill>
           <a:ln/>
         </p:spPr>
+        <p:txBody>
+          <a:bodyPr/>
+          <a:p/>
+        </p:txBody>
       </p:sp>
       <p:sp>
         <p:nvSpPr>
@@ -14439,6 +14947,10 @@
           </a:solidFill>
           <a:ln/>
         </p:spPr>
+        <p:txBody>
+          <a:bodyPr/>
+          <a:p/>
+        </p:txBody>
       </p:sp>
       <p:pic>
         <p:nvPicPr>
@@ -14563,6 +15075,10 @@
           </a:solidFill>
           <a:ln/>
         </p:spPr>
+        <p:txBody>
+          <a:bodyPr/>
+          <a:p/>
+        </p:txBody>
       </p:sp>
       <p:sp>
         <p:nvSpPr>
@@ -14583,6 +15099,10 @@
           </a:solidFill>
           <a:ln/>
         </p:spPr>
+        <p:txBody>
+          <a:bodyPr/>
+          <a:p/>
+        </p:txBody>
       </p:sp>
       <p:pic>
         <p:nvPicPr>
@@ -14707,6 +15227,10 @@
           </a:solidFill>
           <a:ln/>
         </p:spPr>
+        <p:txBody>
+          <a:bodyPr/>
+          <a:p/>
+        </p:txBody>
       </p:sp>
       <p:sp>
         <p:nvSpPr>
@@ -14727,6 +15251,10 @@
           </a:solidFill>
           <a:ln/>
         </p:spPr>
+        <p:txBody>
+          <a:bodyPr/>
+          <a:p/>
+        </p:txBody>
       </p:sp>
       <p:pic>
         <p:nvPicPr>
@@ -14851,6 +15379,10 @@
           </a:solidFill>
           <a:ln/>
         </p:spPr>
+        <p:txBody>
+          <a:bodyPr/>
+          <a:p/>
+        </p:txBody>
       </p:sp>
       <p:sp>
         <p:nvSpPr>
@@ -14871,6 +15403,10 @@
           </a:solidFill>
           <a:ln/>
         </p:spPr>
+        <p:txBody>
+          <a:bodyPr/>
+          <a:p/>
+        </p:txBody>
       </p:sp>
       <p:pic>
         <p:nvPicPr>
@@ -14995,6 +15531,10 @@
           </a:solidFill>
           <a:ln/>
         </p:spPr>
+        <p:txBody>
+          <a:bodyPr/>
+          <a:p/>
+        </p:txBody>
       </p:sp>
       <p:sp>
         <p:nvSpPr>
@@ -15015,6 +15555,10 @@
           </a:solidFill>
           <a:ln/>
         </p:spPr>
+        <p:txBody>
+          <a:bodyPr/>
+          <a:p/>
+        </p:txBody>
       </p:sp>
       <p:pic>
         <p:nvPicPr>
@@ -15139,6 +15683,10 @@
           </a:solidFill>
           <a:ln/>
         </p:spPr>
+        <p:txBody>
+          <a:bodyPr/>
+          <a:p/>
+        </p:txBody>
       </p:sp>
       <p:sp>
         <p:nvSpPr>
@@ -15159,6 +15707,10 @@
           </a:solidFill>
           <a:ln/>
         </p:spPr>
+        <p:txBody>
+          <a:bodyPr/>
+          <a:p/>
+        </p:txBody>
       </p:sp>
       <p:pic>
         <p:nvPicPr>
@@ -15513,6 +16065,10 @@
             </a:outerShdw>
           </a:effectLst>
         </p:spPr>
+        <p:txBody>
+          <a:bodyPr/>
+          <a:p/>
+        </p:txBody>
       </p:sp>
       <p:sp>
         <p:nvSpPr>
@@ -15533,6 +16089,10 @@
           </a:solidFill>
           <a:ln/>
         </p:spPr>
+        <p:txBody>
+          <a:bodyPr/>
+          <a:p/>
+        </p:txBody>
       </p:sp>
       <p:pic>
         <p:nvPicPr>
@@ -15667,6 +16227,10 @@
             </a:outerShdw>
           </a:effectLst>
         </p:spPr>
+        <p:txBody>
+          <a:bodyPr/>
+          <a:p/>
+        </p:txBody>
       </p:sp>
       <p:sp>
         <p:nvSpPr>
@@ -15687,6 +16251,10 @@
           </a:solidFill>
           <a:ln/>
         </p:spPr>
+        <p:txBody>
+          <a:bodyPr/>
+          <a:p/>
+        </p:txBody>
       </p:sp>
       <p:pic>
         <p:nvPicPr>
@@ -15821,6 +16389,10 @@
             </a:outerShdw>
           </a:effectLst>
         </p:spPr>
+        <p:txBody>
+          <a:bodyPr/>
+          <a:p/>
+        </p:txBody>
       </p:sp>
       <p:sp>
         <p:nvSpPr>
@@ -15841,6 +16413,10 @@
           </a:solidFill>
           <a:ln/>
         </p:spPr>
+        <p:txBody>
+          <a:bodyPr/>
+          <a:p/>
+        </p:txBody>
       </p:sp>
       <p:pic>
         <p:nvPicPr>
@@ -15975,6 +16551,10 @@
             </a:outerShdw>
           </a:effectLst>
         </p:spPr>
+        <p:txBody>
+          <a:bodyPr/>
+          <a:p/>
+        </p:txBody>
       </p:sp>
       <p:sp>
         <p:nvSpPr>
@@ -15995,6 +16575,10 @@
           </a:solidFill>
           <a:ln/>
         </p:spPr>
+        <p:txBody>
+          <a:bodyPr/>
+          <a:p/>
+        </p:txBody>
       </p:sp>
       <p:pic>
         <p:nvPicPr>
@@ -16122,6 +16706,10 @@
           </a:solidFill>
           <a:ln/>
         </p:spPr>
+        <p:txBody>
+          <a:bodyPr/>
+          <a:p/>
+        </p:txBody>
       </p:sp>
       <p:sp>
         <p:nvSpPr>
@@ -16391,6 +16979,10 @@
             </a:outerShdw>
           </a:effectLst>
         </p:spPr>
+        <p:txBody>
+          <a:bodyPr/>
+          <a:p/>
+        </p:txBody>
       </p:sp>
       <p:sp>
         <p:nvSpPr>
@@ -16649,6 +17241,10 @@
             </a:outerShdw>
           </a:effectLst>
         </p:spPr>
+        <p:txBody>
+          <a:bodyPr/>
+          <a:p/>
+        </p:txBody>
       </p:sp>
       <p:sp>
         <p:nvSpPr>
@@ -16669,6 +17265,10 @@
           </a:solidFill>
           <a:ln/>
         </p:spPr>
+        <p:txBody>
+          <a:bodyPr/>
+          <a:p/>
+        </p:txBody>
       </p:sp>
       <p:pic>
         <p:nvPicPr>
@@ -18911,6 +19511,10 @@
           </a:solidFill>
           <a:ln/>
         </p:spPr>
+        <p:txBody>
+          <a:bodyPr/>
+          <a:p/>
+        </p:txBody>
       </p:sp>
       <p:pic>
         <p:nvPicPr>
@@ -18960,6 +19564,10 @@
             <a:prstDash val="solid"/>
           </a:ln>
         </p:spPr>
+        <p:txBody>
+          <a:bodyPr/>
+          <a:p/>
+        </p:txBody>
       </p:sp>
       <p:sp>
         <p:nvSpPr>
@@ -19123,6 +19731,10 @@
           </a:solidFill>
           <a:ln/>
         </p:spPr>
+        <p:txBody>
+          <a:bodyPr/>
+          <a:p/>
+        </p:txBody>
       </p:sp>
       <p:sp>
         <p:nvSpPr>
@@ -19143,6 +19755,10 @@
           </a:solidFill>
           <a:ln/>
         </p:spPr>
+        <p:txBody>
+          <a:bodyPr/>
+          <a:p/>
+        </p:txBody>
       </p:sp>
       <p:pic>
         <p:nvPicPr>
@@ -19192,6 +19808,10 @@
             <a:prstDash val="solid"/>
           </a:ln>
         </p:spPr>
+        <p:txBody>
+          <a:bodyPr/>
+          <a:p/>
+        </p:txBody>
       </p:sp>
       <p:sp>
         <p:nvSpPr>
@@ -19355,6 +19975,10 @@
           </a:solidFill>
           <a:ln/>
         </p:spPr>
+        <p:txBody>
+          <a:bodyPr/>
+          <a:p/>
+        </p:txBody>
       </p:sp>
       <p:sp>
         <p:nvSpPr>
@@ -19375,6 +19999,10 @@
           </a:solidFill>
           <a:ln/>
         </p:spPr>
+        <p:txBody>
+          <a:bodyPr/>
+          <a:p/>
+        </p:txBody>
       </p:sp>
       <p:pic>
         <p:nvPicPr>
@@ -19424,6 +20052,10 @@
             <a:prstDash val="solid"/>
           </a:ln>
         </p:spPr>
+        <p:txBody>
+          <a:bodyPr/>
+          <a:p/>
+        </p:txBody>
       </p:sp>
       <p:sp>
         <p:nvSpPr>
@@ -19587,6 +20219,10 @@
           </a:solidFill>
           <a:ln/>
         </p:spPr>
+        <p:txBody>
+          <a:bodyPr/>
+          <a:p/>
+        </p:txBody>
       </p:sp>
       <p:sp>
         <p:nvSpPr>
@@ -19607,6 +20243,10 @@
           </a:solidFill>
           <a:ln/>
         </p:spPr>
+        <p:txBody>
+          <a:bodyPr/>
+          <a:p/>
+        </p:txBody>
       </p:sp>
       <p:pic>
         <p:nvPicPr>
@@ -19656,6 +20296,10 @@
             <a:prstDash val="solid"/>
           </a:ln>
         </p:spPr>
+        <p:txBody>
+          <a:bodyPr/>
+          <a:p/>
+        </p:txBody>
       </p:sp>
       <p:sp>
         <p:nvSpPr>
@@ -19819,6 +20463,10 @@
           </a:solidFill>
           <a:ln/>
         </p:spPr>
+        <p:txBody>
+          <a:bodyPr/>
+          <a:p/>
+        </p:txBody>
       </p:sp>
       <p:sp>
         <p:nvSpPr>
@@ -19839,6 +20487,10 @@
           </a:solidFill>
           <a:ln/>
         </p:spPr>
+        <p:txBody>
+          <a:bodyPr/>
+          <a:p/>
+        </p:txBody>
       </p:sp>
       <p:pic>
         <p:nvPicPr>
@@ -19888,6 +20540,10 @@
             <a:prstDash val="solid"/>
           </a:ln>
         </p:spPr>
+        <p:txBody>
+          <a:bodyPr/>
+          <a:p/>
+        </p:txBody>
       </p:sp>
       <p:sp>
         <p:nvSpPr>
@@ -20051,6 +20707,10 @@
           </a:solidFill>
           <a:ln/>
         </p:spPr>
+        <p:txBody>
+          <a:bodyPr/>
+          <a:p/>
+        </p:txBody>
       </p:sp>
       <p:sp>
         <p:nvSpPr>
@@ -20071,6 +20731,10 @@
           </a:solidFill>
           <a:ln/>
         </p:spPr>
+        <p:txBody>
+          <a:bodyPr/>
+          <a:p/>
+        </p:txBody>
       </p:sp>
       <p:pic>
         <p:nvPicPr>
@@ -20120,6 +20784,10 @@
             <a:prstDash val="solid"/>
           </a:ln>
         </p:spPr>
+        <p:txBody>
+          <a:bodyPr/>
+          <a:p/>
+        </p:txBody>
       </p:sp>
       <p:sp>
         <p:nvSpPr>
@@ -20292,6 +20960,10 @@
             </a:outerShdw>
           </a:effectLst>
         </p:spPr>
+        <p:txBody>
+          <a:bodyPr/>
+          <a:p/>
+        </p:txBody>
       </p:sp>
       <p:sp>
         <p:nvSpPr>
@@ -20554,6 +21226,10 @@
           </a:solidFill>
           <a:ln/>
         </p:spPr>
+        <p:txBody>
+          <a:bodyPr/>
+          <a:p/>
+        </p:txBody>
       </p:sp>
       <p:sp>
         <p:nvSpPr>
@@ -20616,6 +21292,10 @@
           </a:solidFill>
           <a:ln/>
         </p:spPr>
+        <p:txBody>
+          <a:bodyPr/>
+          <a:p/>
+        </p:txBody>
       </p:sp>
       <p:sp>
         <p:nvSpPr>
@@ -20638,6 +21318,10 @@
           </a:solidFill>
           <a:ln/>
         </p:spPr>
+        <p:txBody>
+          <a:bodyPr/>
+          <a:p/>
+        </p:txBody>
       </p:sp>
       <p:sp>
         <p:nvSpPr>
@@ -20700,6 +21384,10 @@
           </a:solidFill>
           <a:ln/>
         </p:spPr>
+        <p:txBody>
+          <a:bodyPr/>
+          <a:p/>
+        </p:txBody>
       </p:sp>
       <p:sp>
         <p:nvSpPr>
@@ -20727,6 +21415,10 @@
             <a:prstDash val="solid"/>
           </a:ln>
         </p:spPr>
+        <p:txBody>
+          <a:bodyPr/>
+          <a:p/>
+        </p:txBody>
       </p:sp>
       <p:sp>
         <p:nvSpPr>
@@ -20788,6 +21480,10 @@
           </a:solidFill>
           <a:ln/>
         </p:spPr>
+        <p:txBody>
+          <a:bodyPr/>
+          <a:p/>
+        </p:txBody>
       </p:sp>
       <p:sp>
         <p:nvSpPr>
@@ -20852,6 +21548,10 @@
           </a:solidFill>
           <a:ln/>
         </p:spPr>
+        <p:txBody>
+          <a:bodyPr/>
+          <a:p/>
+        </p:txBody>
       </p:sp>
       <p:sp>
         <p:nvSpPr>
@@ -20936,6 +21636,10 @@
           </a:solidFill>
           <a:ln/>
         </p:spPr>
+        <p:txBody>
+          <a:bodyPr/>
+          <a:p/>
+        </p:txBody>
       </p:sp>
       <p:sp>
         <p:nvSpPr>
@@ -21020,6 +21724,10 @@
           </a:solidFill>
           <a:ln/>
         </p:spPr>
+        <p:txBody>
+          <a:bodyPr/>
+          <a:p/>
+        </p:txBody>
       </p:sp>
       <p:sp>
         <p:nvSpPr>
@@ -21082,6 +21790,10 @@
           </a:solidFill>
           <a:ln/>
         </p:spPr>
+        <p:txBody>
+          <a:bodyPr/>
+          <a:p/>
+        </p:txBody>
       </p:sp>
       <p:sp>
         <p:nvSpPr>
@@ -21102,6 +21814,10 @@
           </a:solidFill>
           <a:ln/>
         </p:spPr>
+        <p:txBody>
+          <a:bodyPr/>
+          <a:p/>
+        </p:txBody>
       </p:sp>
       <p:sp>
         <p:nvSpPr>
@@ -21122,6 +21838,10 @@
           </a:solidFill>
           <a:ln/>
         </p:spPr>
+        <p:txBody>
+          <a:bodyPr/>
+          <a:p/>
+        </p:txBody>
       </p:sp>
       <p:sp>
         <p:nvSpPr>
@@ -21142,6 +21862,10 @@
           </a:solidFill>
           <a:ln/>
         </p:spPr>
+        <p:txBody>
+          <a:bodyPr/>
+          <a:p/>
+        </p:txBody>
       </p:sp>
       <p:sp>
         <p:nvSpPr>
@@ -21164,6 +21888,10 @@
           </a:solidFill>
           <a:ln/>
         </p:spPr>
+        <p:txBody>
+          <a:bodyPr/>
+          <a:p/>
+        </p:txBody>
       </p:sp>
       <p:sp>
         <p:nvSpPr>
@@ -21268,6 +21996,10 @@
           </a:solidFill>
           <a:ln/>
         </p:spPr>
+        <p:txBody>
+          <a:bodyPr/>
+          <a:p/>
+        </p:txBody>
       </p:sp>
       <p:sp>
         <p:nvSpPr>
@@ -21372,6 +22104,10 @@
           </a:solidFill>
           <a:ln/>
         </p:spPr>
+        <p:txBody>
+          <a:bodyPr/>
+          <a:p/>
+        </p:txBody>
       </p:sp>
       <p:sp>
         <p:nvSpPr>
@@ -21474,6 +22210,10 @@
           </a:solidFill>
           <a:ln/>
         </p:spPr>
+        <p:txBody>
+          <a:bodyPr/>
+          <a:p/>
+        </p:txBody>
       </p:sp>
       <p:sp>
         <p:nvSpPr>
@@ -21496,6 +22236,10 @@
           </a:solidFill>
           <a:ln/>
         </p:spPr>
+        <p:txBody>
+          <a:bodyPr/>
+          <a:p/>
+        </p:txBody>
       </p:sp>
       <p:sp>
         <p:nvSpPr>
@@ -21565,6 +22309,10 @@
             <a:prstDash val="solid"/>
           </a:ln>
         </p:spPr>
+        <p:txBody>
+          <a:bodyPr/>
+          <a:p/>
+        </p:txBody>
       </p:sp>
       <p:sp>
         <p:nvSpPr>
@@ -21585,6 +22333,10 @@
           </a:solidFill>
           <a:ln/>
         </p:spPr>
+        <p:txBody>
+          <a:bodyPr/>
+          <a:p/>
+        </p:txBody>
       </p:sp>
       <p:pic>
         <p:nvPicPr>
@@ -21712,6 +22464,10 @@
           </a:solidFill>
           <a:ln/>
         </p:spPr>
+        <p:txBody>
+          <a:bodyPr/>
+          <a:p/>
+        </p:txBody>
       </p:sp>
       <p:sp>
         <p:nvSpPr>
@@ -21732,6 +22488,10 @@
           </a:solidFill>
           <a:ln/>
         </p:spPr>
+        <p:txBody>
+          <a:bodyPr/>
+          <a:p/>
+        </p:txBody>
       </p:sp>
       <p:pic>
         <p:nvPicPr>
@@ -22047,6 +22807,10 @@
             </a:outerShdw>
           </a:effectLst>
         </p:spPr>
+        <p:txBody>
+          <a:bodyPr/>
+          <a:p/>
+        </p:txBody>
       </p:sp>
       <p:sp>
         <p:nvSpPr>
@@ -22425,6 +23189,10 @@
           </a:solidFill>
           <a:ln/>
         </p:spPr>
+        <p:txBody>
+          <a:bodyPr/>
+          <a:p/>
+        </p:txBody>
       </p:sp>
       <p:sp>
         <p:nvSpPr>
@@ -22445,6 +23213,10 @@
           </a:solidFill>
           <a:ln/>
         </p:spPr>
+        <p:txBody>
+          <a:bodyPr/>
+          <a:p/>
+        </p:txBody>
       </p:sp>
       <p:pic>
         <p:nvPicPr>
@@ -22572,6 +23344,10 @@
           </a:solidFill>
           <a:ln/>
         </p:spPr>
+        <p:txBody>
+          <a:bodyPr/>
+          <a:p/>
+        </p:txBody>
       </p:sp>
       <p:sp>
         <p:nvSpPr>
@@ -22592,6 +23368,10 @@
           </a:solidFill>
           <a:ln/>
         </p:spPr>
+        <p:txBody>
+          <a:bodyPr/>
+          <a:p/>
+        </p:txBody>
       </p:sp>
       <p:pic>
         <p:nvPicPr>
@@ -22719,6 +23499,10 @@
           </a:solidFill>
           <a:ln/>
         </p:spPr>
+        <p:txBody>
+          <a:bodyPr/>
+          <a:p/>
+        </p:txBody>
       </p:sp>
       <p:sp>
         <p:nvSpPr>
@@ -22739,6 +23523,10 @@
           </a:solidFill>
           <a:ln/>
         </p:spPr>
+        <p:txBody>
+          <a:bodyPr/>
+          <a:p/>
+        </p:txBody>
       </p:sp>
       <p:pic>
         <p:nvPicPr>
@@ -22866,6 +23654,10 @@
           </a:solidFill>
           <a:ln/>
         </p:spPr>
+        <p:txBody>
+          <a:bodyPr/>
+          <a:p/>
+        </p:txBody>
       </p:sp>
       <p:sp>
         <p:nvSpPr>
@@ -22886,6 +23678,10 @@
           </a:solidFill>
           <a:ln/>
         </p:spPr>
+        <p:txBody>
+          <a:bodyPr/>
+          <a:p/>
+        </p:txBody>
       </p:sp>
       <p:pic>
         <p:nvPicPr>
@@ -23201,6 +23997,10 @@
             </a:outerShdw>
           </a:effectLst>
         </p:spPr>
+        <p:txBody>
+          <a:bodyPr/>
+          <a:p/>
+        </p:txBody>
       </p:sp>
       <p:sp>
         <p:nvSpPr>
@@ -23221,6 +24021,10 @@
           </a:solidFill>
           <a:ln/>
         </p:spPr>
+        <p:txBody>
+          <a:bodyPr/>
+          <a:p/>
+        </p:txBody>
       </p:sp>
       <p:pic>
         <p:nvPicPr>
@@ -23355,6 +24159,10 @@
             </a:outerShdw>
           </a:effectLst>
         </p:spPr>
+        <p:txBody>
+          <a:bodyPr/>
+          <a:p/>
+        </p:txBody>
       </p:sp>
       <p:sp>
         <p:nvSpPr>
@@ -23375,6 +24183,10 @@
           </a:solidFill>
           <a:ln/>
         </p:spPr>
+        <p:txBody>
+          <a:bodyPr/>
+          <a:p/>
+        </p:txBody>
       </p:sp>
       <p:pic>
         <p:nvPicPr>
@@ -23509,6 +24321,10 @@
             </a:outerShdw>
           </a:effectLst>
         </p:spPr>
+        <p:txBody>
+          <a:bodyPr/>
+          <a:p/>
+        </p:txBody>
       </p:sp>
       <p:sp>
         <p:nvSpPr>
@@ -23529,6 +24345,10 @@
           </a:solidFill>
           <a:ln/>
         </p:spPr>
+        <p:txBody>
+          <a:bodyPr/>
+          <a:p/>
+        </p:txBody>
       </p:sp>
       <p:pic>
         <p:nvPicPr>
@@ -23663,6 +24483,10 @@
             </a:outerShdw>
           </a:effectLst>
         </p:spPr>
+        <p:txBody>
+          <a:bodyPr/>
+          <a:p/>
+        </p:txBody>
       </p:sp>
       <p:sp>
         <p:nvSpPr>
@@ -23683,6 +24507,10 @@
           </a:solidFill>
           <a:ln/>
         </p:spPr>
+        <p:txBody>
+          <a:bodyPr/>
+          <a:p/>
+        </p:txBody>
       </p:sp>
       <p:pic>
         <p:nvPicPr>
@@ -23810,6 +24638,10 @@
           </a:solidFill>
           <a:ln/>
         </p:spPr>
+        <p:txBody>
+          <a:bodyPr/>
+          <a:p/>
+        </p:txBody>
       </p:sp>
       <p:sp>
         <p:nvSpPr>

</xml_diff>